<commit_message>
CAMBIOS PARA OBTENER COSTO DE DEFECTOS EN CERTIFICACION Y PRODUCCION Y VALIDACION DE INSPECCIONES DE PIEL
</commit_message>
<xml_diff>
--- a/50_RECHAZOS/Docs/[QC] Material Rechazado.pptx
+++ b/50_RECHAZOS/Docs/[QC] Material Rechazado.pptx
@@ -5,11 +5,14 @@
     <p:sldMasterId id="2147483648" r:id="rId1"/>
   </p:sldMasterIdLst>
   <p:notesMasterIdLst>
-    <p:notesMasterId r:id="rId4"/>
+    <p:notesMasterId r:id="rId7"/>
   </p:notesMasterIdLst>
   <p:sldIdLst>
     <p:sldId id="344" r:id="rId2"/>
     <p:sldId id="415" r:id="rId3"/>
+    <p:sldId id="417" r:id="rId4"/>
+    <p:sldId id="418" r:id="rId5"/>
+    <p:sldId id="416" r:id="rId6"/>
   </p:sldIdLst>
   <p:sldSz cx="9144000" cy="6858000" type="screen4x3"/>
   <p:notesSz cx="6858000" cy="9144000"/>
@@ -209,7 +212,7 @@
           <a:p>
             <a:fld id="{A17B1792-3256-4E77-8442-3E205CD69EF5}" type="datetimeFigureOut">
               <a:rPr lang="en-US" smtClean="0"/>
-              <a:t>12/6/2021</a:t>
+              <a:t>12/13/2021</a:t>
             </a:fld>
             <a:endParaRPr lang="en-US"/>
           </a:p>
@@ -655,7 +658,7 @@
           <a:p>
             <a:fld id="{07558649-2619-44F9-8F30-2D6466E57529}" type="datetimeFigureOut">
               <a:rPr lang="en-US" smtClean="0"/>
-              <a:t>12/6/2021</a:t>
+              <a:t>12/13/2021</a:t>
             </a:fld>
             <a:endParaRPr lang="en-US"/>
           </a:p>
@@ -823,7 +826,7 @@
           <a:p>
             <a:fld id="{07558649-2619-44F9-8F30-2D6466E57529}" type="datetimeFigureOut">
               <a:rPr lang="en-US" smtClean="0"/>
-              <a:t>12/6/2021</a:t>
+              <a:t>12/13/2021</a:t>
             </a:fld>
             <a:endParaRPr lang="en-US"/>
           </a:p>
@@ -1001,7 +1004,7 @@
           <a:p>
             <a:fld id="{07558649-2619-44F9-8F30-2D6466E57529}" type="datetimeFigureOut">
               <a:rPr lang="en-US" smtClean="0"/>
-              <a:t>12/6/2021</a:t>
+              <a:t>12/13/2021</a:t>
             </a:fld>
             <a:endParaRPr lang="en-US"/>
           </a:p>
@@ -1169,7 +1172,7 @@
           <a:p>
             <a:fld id="{07558649-2619-44F9-8F30-2D6466E57529}" type="datetimeFigureOut">
               <a:rPr lang="en-US" smtClean="0"/>
-              <a:t>12/6/2021</a:t>
+              <a:t>12/13/2021</a:t>
             </a:fld>
             <a:endParaRPr lang="en-US"/>
           </a:p>
@@ -1414,7 +1417,7 @@
           <a:p>
             <a:fld id="{07558649-2619-44F9-8F30-2D6466E57529}" type="datetimeFigureOut">
               <a:rPr lang="en-US" smtClean="0"/>
-              <a:t>12/6/2021</a:t>
+              <a:t>12/13/2021</a:t>
             </a:fld>
             <a:endParaRPr lang="en-US"/>
           </a:p>
@@ -1699,7 +1702,7 @@
           <a:p>
             <a:fld id="{07558649-2619-44F9-8F30-2D6466E57529}" type="datetimeFigureOut">
               <a:rPr lang="en-US" smtClean="0"/>
-              <a:t>12/6/2021</a:t>
+              <a:t>12/13/2021</a:t>
             </a:fld>
             <a:endParaRPr lang="en-US"/>
           </a:p>
@@ -2118,7 +2121,7 @@
           <a:p>
             <a:fld id="{07558649-2619-44F9-8F30-2D6466E57529}" type="datetimeFigureOut">
               <a:rPr lang="en-US" smtClean="0"/>
-              <a:t>12/6/2021</a:t>
+              <a:t>12/13/2021</a:t>
             </a:fld>
             <a:endParaRPr lang="en-US"/>
           </a:p>
@@ -2235,7 +2238,7 @@
           <a:p>
             <a:fld id="{07558649-2619-44F9-8F30-2D6466E57529}" type="datetimeFigureOut">
               <a:rPr lang="en-US" smtClean="0"/>
-              <a:t>12/6/2021</a:t>
+              <a:t>12/13/2021</a:t>
             </a:fld>
             <a:endParaRPr lang="en-US"/>
           </a:p>
@@ -2330,7 +2333,7 @@
           <a:p>
             <a:fld id="{07558649-2619-44F9-8F30-2D6466E57529}" type="datetimeFigureOut">
               <a:rPr lang="en-US" smtClean="0"/>
-              <a:t>12/6/2021</a:t>
+              <a:t>12/13/2021</a:t>
             </a:fld>
             <a:endParaRPr lang="en-US"/>
           </a:p>
@@ -2605,7 +2608,7 @@
           <a:p>
             <a:fld id="{07558649-2619-44F9-8F30-2D6466E57529}" type="datetimeFigureOut">
               <a:rPr lang="en-US" smtClean="0"/>
-              <a:t>12/6/2021</a:t>
+              <a:t>12/13/2021</a:t>
             </a:fld>
             <a:endParaRPr lang="en-US"/>
           </a:p>
@@ -2857,7 +2860,7 @@
           <a:p>
             <a:fld id="{07558649-2619-44F9-8F30-2D6466E57529}" type="datetimeFigureOut">
               <a:rPr lang="en-US" smtClean="0"/>
-              <a:t>12/6/2021</a:t>
+              <a:t>12/13/2021</a:t>
             </a:fld>
             <a:endParaRPr lang="en-US"/>
           </a:p>
@@ -3077,7 +3080,7 @@
           <a:p>
             <a:fld id="{07558649-2619-44F9-8F30-2D6466E57529}" type="datetimeFigureOut">
               <a:rPr lang="en-US" smtClean="0"/>
-              <a:t>12/6/2021</a:t>
+              <a:t>12/13/2021</a:t>
             </a:fld>
             <a:endParaRPr lang="en-US"/>
           </a:p>
@@ -3494,7 +3497,7 @@
               <a:rPr lang="es-MX" b="1" dirty="0">
                 <a:latin typeface="Century Gothic" panose="020B0502020202020204" pitchFamily="34" charset="0"/>
               </a:rPr>
-              <a:t>29/11/2021 – 03/12/2021</a:t>
+              <a:t>06/12/2021 – 10/12/2021</a:t>
             </a:r>
             <a:endParaRPr lang="es-MX" dirty="0">
               <a:latin typeface="Century Gothic" panose="020B0502020202020204" pitchFamily="34" charset="0"/>
@@ -3516,6 +3519,1385 @@
 </file>
 
 <file path=ppt/slides/slide2.xml><?xml version="1.0" encoding="utf-8"?>
+<p:sld xmlns:a="http://schemas.openxmlformats.org/drawingml/2006/main" xmlns:r="http://schemas.openxmlformats.org/officeDocument/2006/relationships" xmlns:p="http://schemas.openxmlformats.org/presentationml/2006/main">
+  <p:cSld>
+    <p:spTree>
+      <p:nvGrpSpPr>
+        <p:cNvPr id="1" name=""/>
+        <p:cNvGrpSpPr/>
+        <p:nvPr/>
+      </p:nvGrpSpPr>
+      <p:grpSpPr>
+        <a:xfrm>
+          <a:off x="0" y="0"/>
+          <a:ext cx="0" cy="0"/>
+          <a:chOff x="0" y="0"/>
+          <a:chExt cx="0" cy="0"/>
+        </a:xfrm>
+      </p:grpSpPr>
+      <p:sp>
+        <p:nvSpPr>
+          <p:cNvPr id="8" name="Title 1"/>
+          <p:cNvSpPr txBox="1">
+            <a:spLocks/>
+          </p:cNvSpPr>
+          <p:nvPr/>
+        </p:nvSpPr>
+        <p:spPr>
+          <a:xfrm>
+            <a:off x="1087408" y="202630"/>
+            <a:ext cx="7229008" cy="634082"/>
+          </a:xfrm>
+          <a:prstGeom prst="rect">
+            <a:avLst/>
+          </a:prstGeom>
+        </p:spPr>
+        <p:txBody>
+          <a:bodyPr/>
+          <a:lstStyle>
+            <a:lvl1pPr algn="ctr" defTabSz="914400" rtl="0" eaLnBrk="1" latinLnBrk="0" hangingPunct="1">
+              <a:spcBef>
+                <a:spcPct val="0"/>
+              </a:spcBef>
+              <a:buNone/>
+              <a:defRPr sz="4400" kern="1200">
+                <a:solidFill>
+                  <a:schemeClr val="tx1"/>
+                </a:solidFill>
+                <a:latin typeface="+mj-lt"/>
+                <a:ea typeface="+mj-ea"/>
+                <a:cs typeface="+mj-cs"/>
+              </a:defRPr>
+            </a:lvl1pPr>
+          </a:lstStyle>
+          <a:p>
+            <a:pPr algn="l"/>
+            <a:r>
+              <a:rPr lang="es-ES" sz="2000" dirty="0" err="1">
+                <a:solidFill>
+                  <a:srgbClr val="3F1900"/>
+                </a:solidFill>
+              </a:rPr>
+              <a:t>Quality</a:t>
+            </a:r>
+            <a:r>
+              <a:rPr lang="es-ES" sz="2000" dirty="0">
+                <a:solidFill>
+                  <a:srgbClr val="3F1900"/>
+                </a:solidFill>
+              </a:rPr>
+              <a:t> </a:t>
+            </a:r>
+            <a:r>
+              <a:rPr lang="es-ES" sz="2000" dirty="0" err="1">
+                <a:solidFill>
+                  <a:srgbClr val="3F1900"/>
+                </a:solidFill>
+              </a:rPr>
+              <a:t>Rejects</a:t>
+            </a:r>
+            <a:r>
+              <a:rPr lang="es-ES" sz="2000" dirty="0">
+                <a:solidFill>
+                  <a:srgbClr val="3F1900"/>
+                </a:solidFill>
+              </a:rPr>
+              <a:t>.</a:t>
+            </a:r>
+            <a:endParaRPr lang="en-US" sz="2000" dirty="0">
+              <a:solidFill>
+                <a:srgbClr val="3F1900"/>
+              </a:solidFill>
+            </a:endParaRPr>
+          </a:p>
+        </p:txBody>
+      </p:sp>
+      <p:sp>
+        <p:nvSpPr>
+          <p:cNvPr id="4" name="Content Placeholder 3"/>
+          <p:cNvSpPr txBox="1">
+            <a:spLocks/>
+          </p:cNvSpPr>
+          <p:nvPr/>
+        </p:nvSpPr>
+        <p:spPr>
+          <a:xfrm>
+            <a:off x="1331640" y="1196753"/>
+            <a:ext cx="7488832" cy="5137780"/>
+          </a:xfrm>
+          <a:prstGeom prst="rect">
+            <a:avLst/>
+          </a:prstGeom>
+        </p:spPr>
+        <p:txBody>
+          <a:bodyPr>
+            <a:normAutofit/>
+          </a:bodyPr>
+          <a:lstStyle>
+            <a:lvl1pPr marL="342900" indent="-342900" algn="l" defTabSz="914400" rtl="0" eaLnBrk="1" latinLnBrk="0" hangingPunct="1">
+              <a:spcBef>
+                <a:spcPct val="20000"/>
+              </a:spcBef>
+              <a:buFont typeface="Arial" panose="020B0604020202020204" pitchFamily="34" charset="0"/>
+              <a:buChar char="•"/>
+              <a:defRPr sz="3200" kern="1200">
+                <a:solidFill>
+                  <a:schemeClr val="tx1"/>
+                </a:solidFill>
+                <a:latin typeface="+mn-lt"/>
+                <a:ea typeface="+mn-ea"/>
+                <a:cs typeface="+mn-cs"/>
+              </a:defRPr>
+            </a:lvl1pPr>
+            <a:lvl2pPr marL="742950" indent="-285750" algn="l" defTabSz="914400" rtl="0" eaLnBrk="1" latinLnBrk="0" hangingPunct="1">
+              <a:spcBef>
+                <a:spcPct val="20000"/>
+              </a:spcBef>
+              <a:buFont typeface="Arial" panose="020B0604020202020204" pitchFamily="34" charset="0"/>
+              <a:buChar char="–"/>
+              <a:defRPr sz="2800" kern="1200">
+                <a:solidFill>
+                  <a:schemeClr val="tx1"/>
+                </a:solidFill>
+                <a:latin typeface="+mn-lt"/>
+                <a:ea typeface="+mn-ea"/>
+                <a:cs typeface="+mn-cs"/>
+              </a:defRPr>
+            </a:lvl2pPr>
+            <a:lvl3pPr marL="1143000" indent="-228600" algn="l" defTabSz="914400" rtl="0" eaLnBrk="1" latinLnBrk="0" hangingPunct="1">
+              <a:spcBef>
+                <a:spcPct val="20000"/>
+              </a:spcBef>
+              <a:buFont typeface="Arial" panose="020B0604020202020204" pitchFamily="34" charset="0"/>
+              <a:buChar char="•"/>
+              <a:defRPr sz="2400" kern="1200">
+                <a:solidFill>
+                  <a:schemeClr val="tx1"/>
+                </a:solidFill>
+                <a:latin typeface="+mn-lt"/>
+                <a:ea typeface="+mn-ea"/>
+                <a:cs typeface="+mn-cs"/>
+              </a:defRPr>
+            </a:lvl3pPr>
+            <a:lvl4pPr marL="1600200" indent="-228600" algn="l" defTabSz="914400" rtl="0" eaLnBrk="1" latinLnBrk="0" hangingPunct="1">
+              <a:spcBef>
+                <a:spcPct val="20000"/>
+              </a:spcBef>
+              <a:buFont typeface="Arial" panose="020B0604020202020204" pitchFamily="34" charset="0"/>
+              <a:buChar char="–"/>
+              <a:defRPr sz="2000" kern="1200">
+                <a:solidFill>
+                  <a:schemeClr val="tx1"/>
+                </a:solidFill>
+                <a:latin typeface="+mn-lt"/>
+                <a:ea typeface="+mn-ea"/>
+                <a:cs typeface="+mn-cs"/>
+              </a:defRPr>
+            </a:lvl4pPr>
+            <a:lvl5pPr marL="2057400" indent="-228600" algn="l" defTabSz="914400" rtl="0" eaLnBrk="1" latinLnBrk="0" hangingPunct="1">
+              <a:spcBef>
+                <a:spcPct val="20000"/>
+              </a:spcBef>
+              <a:buFont typeface="Arial" panose="020B0604020202020204" pitchFamily="34" charset="0"/>
+              <a:buChar char="»"/>
+              <a:defRPr sz="2000" kern="1200">
+                <a:solidFill>
+                  <a:schemeClr val="tx1"/>
+                </a:solidFill>
+                <a:latin typeface="+mn-lt"/>
+                <a:ea typeface="+mn-ea"/>
+                <a:cs typeface="+mn-cs"/>
+              </a:defRPr>
+            </a:lvl5pPr>
+            <a:lvl6pPr marL="2514600" indent="-228600" algn="l" defTabSz="914400" rtl="0" eaLnBrk="1" latinLnBrk="0" hangingPunct="1">
+              <a:spcBef>
+                <a:spcPct val="20000"/>
+              </a:spcBef>
+              <a:buFont typeface="Arial" panose="020B0604020202020204" pitchFamily="34" charset="0"/>
+              <a:buChar char="•"/>
+              <a:defRPr sz="2000" kern="1200">
+                <a:solidFill>
+                  <a:schemeClr val="tx1"/>
+                </a:solidFill>
+                <a:latin typeface="+mn-lt"/>
+                <a:ea typeface="+mn-ea"/>
+                <a:cs typeface="+mn-cs"/>
+              </a:defRPr>
+            </a:lvl6pPr>
+            <a:lvl7pPr marL="2971800" indent="-228600" algn="l" defTabSz="914400" rtl="0" eaLnBrk="1" latinLnBrk="0" hangingPunct="1">
+              <a:spcBef>
+                <a:spcPct val="20000"/>
+              </a:spcBef>
+              <a:buFont typeface="Arial" panose="020B0604020202020204" pitchFamily="34" charset="0"/>
+              <a:buChar char="•"/>
+              <a:defRPr sz="2000" kern="1200">
+                <a:solidFill>
+                  <a:schemeClr val="tx1"/>
+                </a:solidFill>
+                <a:latin typeface="+mn-lt"/>
+                <a:ea typeface="+mn-ea"/>
+                <a:cs typeface="+mn-cs"/>
+              </a:defRPr>
+            </a:lvl7pPr>
+            <a:lvl8pPr marL="3429000" indent="-228600" algn="l" defTabSz="914400" rtl="0" eaLnBrk="1" latinLnBrk="0" hangingPunct="1">
+              <a:spcBef>
+                <a:spcPct val="20000"/>
+              </a:spcBef>
+              <a:buFont typeface="Arial" panose="020B0604020202020204" pitchFamily="34" charset="0"/>
+              <a:buChar char="•"/>
+              <a:defRPr sz="2000" kern="1200">
+                <a:solidFill>
+                  <a:schemeClr val="tx1"/>
+                </a:solidFill>
+                <a:latin typeface="+mn-lt"/>
+                <a:ea typeface="+mn-ea"/>
+                <a:cs typeface="+mn-cs"/>
+              </a:defRPr>
+            </a:lvl8pPr>
+            <a:lvl9pPr marL="3886200" indent="-228600" algn="l" defTabSz="914400" rtl="0" eaLnBrk="1" latinLnBrk="0" hangingPunct="1">
+              <a:spcBef>
+                <a:spcPct val="20000"/>
+              </a:spcBef>
+              <a:buFont typeface="Arial" panose="020B0604020202020204" pitchFamily="34" charset="0"/>
+              <a:buChar char="•"/>
+              <a:defRPr sz="2000" kern="1200">
+                <a:solidFill>
+                  <a:schemeClr val="tx1"/>
+                </a:solidFill>
+                <a:latin typeface="+mn-lt"/>
+                <a:ea typeface="+mn-ea"/>
+                <a:cs typeface="+mn-cs"/>
+              </a:defRPr>
+            </a:lvl9pPr>
+          </a:lstStyle>
+          <a:p>
+            <a:pPr marL="0" indent="0" algn="just">
+              <a:buFont typeface="Arial" panose="020B0604020202020204" pitchFamily="34" charset="0"/>
+              <a:buNone/>
+            </a:pPr>
+            <a:endParaRPr lang="en-US" sz="2000" i="1"/>
+          </a:p>
+        </p:txBody>
+      </p:sp>
+      <p:sp>
+        <p:nvSpPr>
+          <p:cNvPr id="9" name="Rectangle 9">
+            <a:extLst>
+              <a:ext uri="{FF2B5EF4-FFF2-40B4-BE49-F238E27FC236}">
+                <a16:creationId xmlns:a16="http://schemas.microsoft.com/office/drawing/2014/main" id="{F1A6E0C6-DADC-4B10-8F5F-048CE74BBF1F}"/>
+              </a:ext>
+            </a:extLst>
+          </p:cNvPr>
+          <p:cNvSpPr/>
+          <p:nvPr/>
+        </p:nvSpPr>
+        <p:spPr>
+          <a:xfrm>
+            <a:off x="1115616" y="980728"/>
+            <a:ext cx="7956376" cy="276999"/>
+          </a:xfrm>
+          <a:prstGeom prst="rect">
+            <a:avLst/>
+          </a:prstGeom>
+        </p:spPr>
+        <p:txBody>
+          <a:bodyPr wrap="square">
+            <a:spAutoFit/>
+          </a:bodyPr>
+          <a:lstStyle/>
+          <a:p>
+            <a:pPr>
+              <a:buFont typeface="Arial" panose="020B0604020202020204" pitchFamily="34" charset="0"/>
+              <a:buChar char="•"/>
+            </a:pPr>
+            <a:r>
+              <a:rPr lang="es-ES" sz="1200" dirty="0">
+                <a:solidFill>
+                  <a:srgbClr val="222222"/>
+                </a:solidFill>
+                <a:latin typeface="Segoe UI" panose="020B0502040204020203" pitchFamily="34" charset="0"/>
+              </a:rPr>
+              <a:t> Modificación de la vista y lógica para la opción </a:t>
+            </a:r>
+            <a:r>
+              <a:rPr lang="es-ES" sz="1200" b="1" dirty="0">
+                <a:solidFill>
+                  <a:srgbClr val="222222"/>
+                </a:solidFill>
+                <a:latin typeface="Segoe UI" panose="020B0502040204020203" pitchFamily="34" charset="0"/>
+              </a:rPr>
+              <a:t>Liberar Orden.</a:t>
+            </a:r>
+            <a:endParaRPr lang="es-ES" sz="1200" b="0" i="0" dirty="0">
+              <a:solidFill>
+                <a:srgbClr val="222222"/>
+              </a:solidFill>
+              <a:effectLst/>
+              <a:latin typeface="Segoe UI" panose="020B0502040204020203" pitchFamily="34" charset="0"/>
+            </a:endParaRPr>
+          </a:p>
+        </p:txBody>
+      </p:sp>
+      <p:pic>
+        <p:nvPicPr>
+          <p:cNvPr id="5" name="Imagen 4">
+            <a:extLst>
+              <a:ext uri="{FF2B5EF4-FFF2-40B4-BE49-F238E27FC236}">
+                <a16:creationId xmlns:a16="http://schemas.microsoft.com/office/drawing/2014/main" id="{AA625BE9-8895-4240-A92E-09B68819BF0E}"/>
+              </a:ext>
+            </a:extLst>
+          </p:cNvPr>
+          <p:cNvPicPr>
+            <a:picLocks noChangeAspect="1"/>
+          </p:cNvPicPr>
+          <p:nvPr/>
+        </p:nvPicPr>
+        <p:blipFill>
+          <a:blip r:embed="rId2"/>
+          <a:stretch>
+            <a:fillRect/>
+          </a:stretch>
+        </p:blipFill>
+        <p:spPr>
+          <a:xfrm>
+            <a:off x="1115616" y="1412776"/>
+            <a:ext cx="7956376" cy="5400600"/>
+          </a:xfrm>
+          <a:prstGeom prst="rect">
+            <a:avLst/>
+          </a:prstGeom>
+        </p:spPr>
+      </p:pic>
+      <p:sp>
+        <p:nvSpPr>
+          <p:cNvPr id="14" name="CuadroTexto 13">
+            <a:extLst>
+              <a:ext uri="{FF2B5EF4-FFF2-40B4-BE49-F238E27FC236}">
+                <a16:creationId xmlns:a16="http://schemas.microsoft.com/office/drawing/2014/main" id="{3F0652A4-91B4-47A6-81AC-985FD9BD1941}"/>
+              </a:ext>
+            </a:extLst>
+          </p:cNvPr>
+          <p:cNvSpPr txBox="1"/>
+          <p:nvPr/>
+        </p:nvSpPr>
+        <p:spPr>
+          <a:xfrm>
+            <a:off x="4283968" y="1412776"/>
+            <a:ext cx="1800200" cy="738664"/>
+          </a:xfrm>
+          <a:prstGeom prst="rect">
+            <a:avLst/>
+          </a:prstGeom>
+          <a:solidFill>
+            <a:schemeClr val="bg1"/>
+          </a:solidFill>
+          <a:ln w="19050">
+            <a:solidFill>
+              <a:srgbClr val="0070C0"/>
+            </a:solidFill>
+          </a:ln>
+        </p:spPr>
+        <p:txBody>
+          <a:bodyPr wrap="square" rtlCol="0">
+            <a:spAutoFit/>
+          </a:bodyPr>
+          <a:lstStyle/>
+          <a:p>
+            <a:pPr algn="just"/>
+            <a:r>
+              <a:rPr lang="en-US" sz="1050" b="1" dirty="0"/>
+              <a:t>Se </a:t>
+            </a:r>
+            <a:r>
+              <a:rPr lang="en-US" sz="1050" b="1" dirty="0" err="1"/>
+              <a:t>modificación</a:t>
+            </a:r>
+            <a:r>
+              <a:rPr lang="en-US" sz="1050" b="1" dirty="0"/>
+              <a:t> de la vista y </a:t>
+            </a:r>
+            <a:r>
+              <a:rPr lang="en-US" sz="1050" b="1" dirty="0" err="1"/>
+              <a:t>logica</a:t>
+            </a:r>
+            <a:r>
+              <a:rPr lang="en-US" sz="1050" b="1" dirty="0"/>
+              <a:t> para </a:t>
+            </a:r>
+            <a:r>
+              <a:rPr lang="en-US" sz="1050" b="1" dirty="0" err="1"/>
+              <a:t>calcular</a:t>
+            </a:r>
+            <a:r>
+              <a:rPr lang="en-US" sz="1050" b="1" dirty="0"/>
+              <a:t> los PPM’S </a:t>
+            </a:r>
+            <a:r>
+              <a:rPr lang="en-US" sz="1050" b="1" dirty="0" err="1"/>
+              <a:t>en</a:t>
+            </a:r>
+            <a:r>
+              <a:rPr lang="en-US" sz="1050" b="1" dirty="0"/>
+              <a:t> </a:t>
+            </a:r>
+            <a:r>
+              <a:rPr lang="en-US" sz="1050" b="1" dirty="0" err="1"/>
+              <a:t>opción</a:t>
+            </a:r>
+            <a:r>
+              <a:rPr lang="en-US" sz="1050" b="1" dirty="0"/>
+              <a:t> </a:t>
+            </a:r>
+            <a:r>
+              <a:rPr lang="en-US" sz="1050" b="1" dirty="0" err="1"/>
+              <a:t>Liberar</a:t>
+            </a:r>
+            <a:r>
+              <a:rPr lang="en-US" sz="1050" b="1" dirty="0"/>
+              <a:t> </a:t>
+            </a:r>
+            <a:r>
+              <a:rPr lang="en-US" sz="1050" b="1" dirty="0" err="1"/>
+              <a:t>orden</a:t>
+            </a:r>
+            <a:r>
+              <a:rPr lang="en-US" sz="1050" b="1" dirty="0"/>
+              <a:t>.</a:t>
+            </a:r>
+          </a:p>
+        </p:txBody>
+      </p:sp>
+      <p:cxnSp>
+        <p:nvCxnSpPr>
+          <p:cNvPr id="15" name="Conector recto de flecha 14">
+            <a:extLst>
+              <a:ext uri="{FF2B5EF4-FFF2-40B4-BE49-F238E27FC236}">
+                <a16:creationId xmlns:a16="http://schemas.microsoft.com/office/drawing/2014/main" id="{EDB0D253-D9D7-44DF-B280-BA9098BF3E71}"/>
+              </a:ext>
+            </a:extLst>
+          </p:cNvPr>
+          <p:cNvCxnSpPr>
+            <a:cxnSpLocks/>
+            <a:stCxn id="14" idx="1"/>
+          </p:cNvCxnSpPr>
+          <p:nvPr/>
+        </p:nvCxnSpPr>
+        <p:spPr>
+          <a:xfrm flipH="1">
+            <a:off x="3931066" y="1782108"/>
+            <a:ext cx="352902" cy="901271"/>
+          </a:xfrm>
+          <a:prstGeom prst="straightConnector1">
+            <a:avLst/>
+          </a:prstGeom>
+          <a:ln w="28575">
+            <a:solidFill>
+              <a:srgbClr val="0070C0"/>
+            </a:solidFill>
+            <a:tailEnd type="triangle"/>
+          </a:ln>
+        </p:spPr>
+        <p:style>
+          <a:lnRef idx="1">
+            <a:schemeClr val="accent2"/>
+          </a:lnRef>
+          <a:fillRef idx="0">
+            <a:schemeClr val="accent2"/>
+          </a:fillRef>
+          <a:effectRef idx="0">
+            <a:schemeClr val="accent2"/>
+          </a:effectRef>
+          <a:fontRef idx="minor">
+            <a:schemeClr val="tx1"/>
+          </a:fontRef>
+        </p:style>
+      </p:cxnSp>
+    </p:spTree>
+    <p:extLst>
+      <p:ext uri="{BB962C8B-B14F-4D97-AF65-F5344CB8AC3E}">
+        <p14:creationId xmlns:p14="http://schemas.microsoft.com/office/powerpoint/2010/main" val="941744193"/>
+      </p:ext>
+    </p:extLst>
+  </p:cSld>
+  <p:clrMapOvr>
+    <a:masterClrMapping/>
+  </p:clrMapOvr>
+</p:sld>
+</file>
+
+<file path=ppt/slides/slide3.xml><?xml version="1.0" encoding="utf-8"?>
+<p:sld xmlns:a="http://schemas.openxmlformats.org/drawingml/2006/main" xmlns:r="http://schemas.openxmlformats.org/officeDocument/2006/relationships" xmlns:p="http://schemas.openxmlformats.org/presentationml/2006/main">
+  <p:cSld>
+    <p:spTree>
+      <p:nvGrpSpPr>
+        <p:cNvPr id="1" name=""/>
+        <p:cNvGrpSpPr/>
+        <p:nvPr/>
+      </p:nvGrpSpPr>
+      <p:grpSpPr>
+        <a:xfrm>
+          <a:off x="0" y="0"/>
+          <a:ext cx="0" cy="0"/>
+          <a:chOff x="0" y="0"/>
+          <a:chExt cx="0" cy="0"/>
+        </a:xfrm>
+      </p:grpSpPr>
+      <p:sp>
+        <p:nvSpPr>
+          <p:cNvPr id="8" name="Title 1"/>
+          <p:cNvSpPr txBox="1">
+            <a:spLocks/>
+          </p:cNvSpPr>
+          <p:nvPr/>
+        </p:nvSpPr>
+        <p:spPr>
+          <a:xfrm>
+            <a:off x="1087408" y="202630"/>
+            <a:ext cx="7229008" cy="634082"/>
+          </a:xfrm>
+          <a:prstGeom prst="rect">
+            <a:avLst/>
+          </a:prstGeom>
+        </p:spPr>
+        <p:txBody>
+          <a:bodyPr/>
+          <a:lstStyle>
+            <a:lvl1pPr algn="ctr" defTabSz="914400" rtl="0" eaLnBrk="1" latinLnBrk="0" hangingPunct="1">
+              <a:spcBef>
+                <a:spcPct val="0"/>
+              </a:spcBef>
+              <a:buNone/>
+              <a:defRPr sz="4400" kern="1200">
+                <a:solidFill>
+                  <a:schemeClr val="tx1"/>
+                </a:solidFill>
+                <a:latin typeface="+mj-lt"/>
+                <a:ea typeface="+mj-ea"/>
+                <a:cs typeface="+mj-cs"/>
+              </a:defRPr>
+            </a:lvl1pPr>
+          </a:lstStyle>
+          <a:p>
+            <a:pPr algn="l"/>
+            <a:r>
+              <a:rPr lang="es-ES" sz="2000" dirty="0" err="1">
+                <a:solidFill>
+                  <a:srgbClr val="3F1900"/>
+                </a:solidFill>
+              </a:rPr>
+              <a:t>Quality</a:t>
+            </a:r>
+            <a:r>
+              <a:rPr lang="es-ES" sz="2000" dirty="0">
+                <a:solidFill>
+                  <a:srgbClr val="3F1900"/>
+                </a:solidFill>
+              </a:rPr>
+              <a:t> </a:t>
+            </a:r>
+            <a:r>
+              <a:rPr lang="es-ES" sz="2000" dirty="0" err="1">
+                <a:solidFill>
+                  <a:srgbClr val="3F1900"/>
+                </a:solidFill>
+              </a:rPr>
+              <a:t>Rejects</a:t>
+            </a:r>
+            <a:r>
+              <a:rPr lang="es-ES" sz="2000" dirty="0">
+                <a:solidFill>
+                  <a:srgbClr val="3F1900"/>
+                </a:solidFill>
+              </a:rPr>
+              <a:t>.</a:t>
+            </a:r>
+            <a:endParaRPr lang="en-US" sz="2000" dirty="0">
+              <a:solidFill>
+                <a:srgbClr val="3F1900"/>
+              </a:solidFill>
+            </a:endParaRPr>
+          </a:p>
+        </p:txBody>
+      </p:sp>
+      <p:sp>
+        <p:nvSpPr>
+          <p:cNvPr id="4" name="Content Placeholder 3"/>
+          <p:cNvSpPr txBox="1">
+            <a:spLocks/>
+          </p:cNvSpPr>
+          <p:nvPr/>
+        </p:nvSpPr>
+        <p:spPr>
+          <a:xfrm>
+            <a:off x="1331640" y="1196753"/>
+            <a:ext cx="7488832" cy="5137780"/>
+          </a:xfrm>
+          <a:prstGeom prst="rect">
+            <a:avLst/>
+          </a:prstGeom>
+        </p:spPr>
+        <p:txBody>
+          <a:bodyPr>
+            <a:normAutofit/>
+          </a:bodyPr>
+          <a:lstStyle>
+            <a:lvl1pPr marL="342900" indent="-342900" algn="l" defTabSz="914400" rtl="0" eaLnBrk="1" latinLnBrk="0" hangingPunct="1">
+              <a:spcBef>
+                <a:spcPct val="20000"/>
+              </a:spcBef>
+              <a:buFont typeface="Arial" panose="020B0604020202020204" pitchFamily="34" charset="0"/>
+              <a:buChar char="•"/>
+              <a:defRPr sz="3200" kern="1200">
+                <a:solidFill>
+                  <a:schemeClr val="tx1"/>
+                </a:solidFill>
+                <a:latin typeface="+mn-lt"/>
+                <a:ea typeface="+mn-ea"/>
+                <a:cs typeface="+mn-cs"/>
+              </a:defRPr>
+            </a:lvl1pPr>
+            <a:lvl2pPr marL="742950" indent="-285750" algn="l" defTabSz="914400" rtl="0" eaLnBrk="1" latinLnBrk="0" hangingPunct="1">
+              <a:spcBef>
+                <a:spcPct val="20000"/>
+              </a:spcBef>
+              <a:buFont typeface="Arial" panose="020B0604020202020204" pitchFamily="34" charset="0"/>
+              <a:buChar char="–"/>
+              <a:defRPr sz="2800" kern="1200">
+                <a:solidFill>
+                  <a:schemeClr val="tx1"/>
+                </a:solidFill>
+                <a:latin typeface="+mn-lt"/>
+                <a:ea typeface="+mn-ea"/>
+                <a:cs typeface="+mn-cs"/>
+              </a:defRPr>
+            </a:lvl2pPr>
+            <a:lvl3pPr marL="1143000" indent="-228600" algn="l" defTabSz="914400" rtl="0" eaLnBrk="1" latinLnBrk="0" hangingPunct="1">
+              <a:spcBef>
+                <a:spcPct val="20000"/>
+              </a:spcBef>
+              <a:buFont typeface="Arial" panose="020B0604020202020204" pitchFamily="34" charset="0"/>
+              <a:buChar char="•"/>
+              <a:defRPr sz="2400" kern="1200">
+                <a:solidFill>
+                  <a:schemeClr val="tx1"/>
+                </a:solidFill>
+                <a:latin typeface="+mn-lt"/>
+                <a:ea typeface="+mn-ea"/>
+                <a:cs typeface="+mn-cs"/>
+              </a:defRPr>
+            </a:lvl3pPr>
+            <a:lvl4pPr marL="1600200" indent="-228600" algn="l" defTabSz="914400" rtl="0" eaLnBrk="1" latinLnBrk="0" hangingPunct="1">
+              <a:spcBef>
+                <a:spcPct val="20000"/>
+              </a:spcBef>
+              <a:buFont typeface="Arial" panose="020B0604020202020204" pitchFamily="34" charset="0"/>
+              <a:buChar char="–"/>
+              <a:defRPr sz="2000" kern="1200">
+                <a:solidFill>
+                  <a:schemeClr val="tx1"/>
+                </a:solidFill>
+                <a:latin typeface="+mn-lt"/>
+                <a:ea typeface="+mn-ea"/>
+                <a:cs typeface="+mn-cs"/>
+              </a:defRPr>
+            </a:lvl4pPr>
+            <a:lvl5pPr marL="2057400" indent="-228600" algn="l" defTabSz="914400" rtl="0" eaLnBrk="1" latinLnBrk="0" hangingPunct="1">
+              <a:spcBef>
+                <a:spcPct val="20000"/>
+              </a:spcBef>
+              <a:buFont typeface="Arial" panose="020B0604020202020204" pitchFamily="34" charset="0"/>
+              <a:buChar char="»"/>
+              <a:defRPr sz="2000" kern="1200">
+                <a:solidFill>
+                  <a:schemeClr val="tx1"/>
+                </a:solidFill>
+                <a:latin typeface="+mn-lt"/>
+                <a:ea typeface="+mn-ea"/>
+                <a:cs typeface="+mn-cs"/>
+              </a:defRPr>
+            </a:lvl5pPr>
+            <a:lvl6pPr marL="2514600" indent="-228600" algn="l" defTabSz="914400" rtl="0" eaLnBrk="1" latinLnBrk="0" hangingPunct="1">
+              <a:spcBef>
+                <a:spcPct val="20000"/>
+              </a:spcBef>
+              <a:buFont typeface="Arial" panose="020B0604020202020204" pitchFamily="34" charset="0"/>
+              <a:buChar char="•"/>
+              <a:defRPr sz="2000" kern="1200">
+                <a:solidFill>
+                  <a:schemeClr val="tx1"/>
+                </a:solidFill>
+                <a:latin typeface="+mn-lt"/>
+                <a:ea typeface="+mn-ea"/>
+                <a:cs typeface="+mn-cs"/>
+              </a:defRPr>
+            </a:lvl6pPr>
+            <a:lvl7pPr marL="2971800" indent="-228600" algn="l" defTabSz="914400" rtl="0" eaLnBrk="1" latinLnBrk="0" hangingPunct="1">
+              <a:spcBef>
+                <a:spcPct val="20000"/>
+              </a:spcBef>
+              <a:buFont typeface="Arial" panose="020B0604020202020204" pitchFamily="34" charset="0"/>
+              <a:buChar char="•"/>
+              <a:defRPr sz="2000" kern="1200">
+                <a:solidFill>
+                  <a:schemeClr val="tx1"/>
+                </a:solidFill>
+                <a:latin typeface="+mn-lt"/>
+                <a:ea typeface="+mn-ea"/>
+                <a:cs typeface="+mn-cs"/>
+              </a:defRPr>
+            </a:lvl7pPr>
+            <a:lvl8pPr marL="3429000" indent="-228600" algn="l" defTabSz="914400" rtl="0" eaLnBrk="1" latinLnBrk="0" hangingPunct="1">
+              <a:spcBef>
+                <a:spcPct val="20000"/>
+              </a:spcBef>
+              <a:buFont typeface="Arial" panose="020B0604020202020204" pitchFamily="34" charset="0"/>
+              <a:buChar char="•"/>
+              <a:defRPr sz="2000" kern="1200">
+                <a:solidFill>
+                  <a:schemeClr val="tx1"/>
+                </a:solidFill>
+                <a:latin typeface="+mn-lt"/>
+                <a:ea typeface="+mn-ea"/>
+                <a:cs typeface="+mn-cs"/>
+              </a:defRPr>
+            </a:lvl8pPr>
+            <a:lvl9pPr marL="3886200" indent="-228600" algn="l" defTabSz="914400" rtl="0" eaLnBrk="1" latinLnBrk="0" hangingPunct="1">
+              <a:spcBef>
+                <a:spcPct val="20000"/>
+              </a:spcBef>
+              <a:buFont typeface="Arial" panose="020B0604020202020204" pitchFamily="34" charset="0"/>
+              <a:buChar char="•"/>
+              <a:defRPr sz="2000" kern="1200">
+                <a:solidFill>
+                  <a:schemeClr val="tx1"/>
+                </a:solidFill>
+                <a:latin typeface="+mn-lt"/>
+                <a:ea typeface="+mn-ea"/>
+                <a:cs typeface="+mn-cs"/>
+              </a:defRPr>
+            </a:lvl9pPr>
+          </a:lstStyle>
+          <a:p>
+            <a:pPr marL="0" indent="0" algn="just">
+              <a:buFont typeface="Arial" panose="020B0604020202020204" pitchFamily="34" charset="0"/>
+              <a:buNone/>
+            </a:pPr>
+            <a:endParaRPr lang="en-US" sz="2000" i="1"/>
+          </a:p>
+        </p:txBody>
+      </p:sp>
+      <p:sp>
+        <p:nvSpPr>
+          <p:cNvPr id="9" name="Rectangle 9">
+            <a:extLst>
+              <a:ext uri="{FF2B5EF4-FFF2-40B4-BE49-F238E27FC236}">
+                <a16:creationId xmlns:a16="http://schemas.microsoft.com/office/drawing/2014/main" id="{F1A6E0C6-DADC-4B10-8F5F-048CE74BBF1F}"/>
+              </a:ext>
+            </a:extLst>
+          </p:cNvPr>
+          <p:cNvSpPr/>
+          <p:nvPr/>
+        </p:nvSpPr>
+        <p:spPr>
+          <a:xfrm>
+            <a:off x="1115616" y="980728"/>
+            <a:ext cx="7956376" cy="276999"/>
+          </a:xfrm>
+          <a:prstGeom prst="rect">
+            <a:avLst/>
+          </a:prstGeom>
+        </p:spPr>
+        <p:txBody>
+          <a:bodyPr wrap="square">
+            <a:spAutoFit/>
+          </a:bodyPr>
+          <a:lstStyle/>
+          <a:p>
+            <a:pPr>
+              <a:buFont typeface="Arial" panose="020B0604020202020204" pitchFamily="34" charset="0"/>
+              <a:buChar char="•"/>
+            </a:pPr>
+            <a:r>
+              <a:rPr lang="es-ES" sz="1200" dirty="0">
+                <a:solidFill>
+                  <a:srgbClr val="222222"/>
+                </a:solidFill>
+                <a:latin typeface="Segoe UI" panose="020B0502040204020203" pitchFamily="34" charset="0"/>
+              </a:rPr>
+              <a:t> Modificación de la vista y lógica para la opción </a:t>
+            </a:r>
+            <a:r>
+              <a:rPr lang="es-ES" sz="1200" b="1" dirty="0">
+                <a:solidFill>
+                  <a:srgbClr val="222222"/>
+                </a:solidFill>
+                <a:latin typeface="Segoe UI" panose="020B0502040204020203" pitchFamily="34" charset="0"/>
+              </a:rPr>
+              <a:t>Liberar Orden.</a:t>
+            </a:r>
+            <a:endParaRPr lang="es-ES" sz="1200" b="0" i="0" dirty="0">
+              <a:solidFill>
+                <a:srgbClr val="222222"/>
+              </a:solidFill>
+              <a:effectLst/>
+              <a:latin typeface="Segoe UI" panose="020B0502040204020203" pitchFamily="34" charset="0"/>
+            </a:endParaRPr>
+          </a:p>
+        </p:txBody>
+      </p:sp>
+      <p:pic>
+        <p:nvPicPr>
+          <p:cNvPr id="3" name="Imagen 2">
+            <a:extLst>
+              <a:ext uri="{FF2B5EF4-FFF2-40B4-BE49-F238E27FC236}">
+                <a16:creationId xmlns:a16="http://schemas.microsoft.com/office/drawing/2014/main" id="{3D348ACD-8A2F-4B31-9D94-3F8483601936}"/>
+              </a:ext>
+            </a:extLst>
+          </p:cNvPr>
+          <p:cNvPicPr>
+            <a:picLocks noChangeAspect="1"/>
+          </p:cNvPicPr>
+          <p:nvPr/>
+        </p:nvPicPr>
+        <p:blipFill>
+          <a:blip r:embed="rId2"/>
+          <a:stretch>
+            <a:fillRect/>
+          </a:stretch>
+        </p:blipFill>
+        <p:spPr>
+          <a:xfrm>
+            <a:off x="1331640" y="1257727"/>
+            <a:ext cx="7632848" cy="5397643"/>
+          </a:xfrm>
+          <a:prstGeom prst="rect">
+            <a:avLst/>
+          </a:prstGeom>
+        </p:spPr>
+      </p:pic>
+      <p:sp>
+        <p:nvSpPr>
+          <p:cNvPr id="10" name="CuadroTexto 9">
+            <a:extLst>
+              <a:ext uri="{FF2B5EF4-FFF2-40B4-BE49-F238E27FC236}">
+                <a16:creationId xmlns:a16="http://schemas.microsoft.com/office/drawing/2014/main" id="{C1CE455E-4E6A-46B2-B52B-2FD7A77C070B}"/>
+              </a:ext>
+            </a:extLst>
+          </p:cNvPr>
+          <p:cNvSpPr txBox="1"/>
+          <p:nvPr/>
+        </p:nvSpPr>
+        <p:spPr>
+          <a:xfrm>
+            <a:off x="1475656" y="1483767"/>
+            <a:ext cx="3744416" cy="577081"/>
+          </a:xfrm>
+          <a:prstGeom prst="rect">
+            <a:avLst/>
+          </a:prstGeom>
+          <a:solidFill>
+            <a:schemeClr val="bg1"/>
+          </a:solidFill>
+          <a:ln w="19050">
+            <a:solidFill>
+              <a:srgbClr val="0070C0"/>
+            </a:solidFill>
+          </a:ln>
+        </p:spPr>
+        <p:txBody>
+          <a:bodyPr wrap="square" rtlCol="0">
+            <a:spAutoFit/>
+          </a:bodyPr>
+          <a:lstStyle/>
+          <a:p>
+            <a:pPr algn="just"/>
+            <a:r>
+              <a:rPr lang="en-US" sz="1050" b="1" dirty="0"/>
+              <a:t>Para la </a:t>
+            </a:r>
+            <a:r>
+              <a:rPr lang="en-US" sz="1050" b="1" dirty="0" err="1"/>
+              <a:t>captura</a:t>
+            </a:r>
+            <a:r>
+              <a:rPr lang="en-US" sz="1050" b="1" dirty="0"/>
+              <a:t> del Jefe de </a:t>
+            </a:r>
+            <a:r>
+              <a:rPr lang="en-US" sz="1050" b="1" dirty="0" err="1"/>
+              <a:t>grupo</a:t>
+            </a:r>
+            <a:r>
+              <a:rPr lang="en-US" sz="1050" b="1" dirty="0"/>
+              <a:t> e Inspector de </a:t>
+            </a:r>
+            <a:r>
+              <a:rPr lang="en-US" sz="1050" b="1" dirty="0" err="1"/>
+              <a:t>producción</a:t>
+            </a:r>
+            <a:r>
+              <a:rPr lang="en-US" sz="1050" b="1" dirty="0"/>
+              <a:t> se </a:t>
+            </a:r>
+            <a:r>
+              <a:rPr lang="en-US" sz="1050" b="1" dirty="0" err="1"/>
+              <a:t>programo</a:t>
+            </a:r>
+            <a:r>
+              <a:rPr lang="en-US" sz="1050" b="1" dirty="0"/>
+              <a:t> </a:t>
+            </a:r>
+            <a:r>
+              <a:rPr lang="en-US" sz="1050" b="1" dirty="0" err="1"/>
+              <a:t>el</a:t>
+            </a:r>
+            <a:r>
+              <a:rPr lang="en-US" sz="1050" b="1" dirty="0"/>
+              <a:t> campo para que solo </a:t>
+            </a:r>
+            <a:r>
+              <a:rPr lang="en-US" sz="1050" b="1" dirty="0" err="1"/>
+              <a:t>permita</a:t>
+            </a:r>
+            <a:r>
+              <a:rPr lang="en-US" sz="1050" b="1" dirty="0"/>
+              <a:t> </a:t>
+            </a:r>
+            <a:r>
+              <a:rPr lang="en-US" sz="1050" b="1" dirty="0" err="1"/>
+              <a:t>capturar</a:t>
+            </a:r>
+            <a:r>
+              <a:rPr lang="en-US" sz="1050" b="1" dirty="0"/>
+              <a:t> </a:t>
+            </a:r>
+            <a:r>
+              <a:rPr lang="en-US" sz="1050" b="1" dirty="0" err="1"/>
+              <a:t>información</a:t>
+            </a:r>
+            <a:r>
+              <a:rPr lang="en-US" sz="1050" b="1" dirty="0"/>
+              <a:t> </a:t>
+            </a:r>
+            <a:r>
+              <a:rPr lang="en-US" sz="1050" b="1" dirty="0" err="1"/>
+              <a:t>valida</a:t>
+            </a:r>
+            <a:r>
+              <a:rPr lang="en-US" sz="1050" b="1" dirty="0"/>
+              <a:t>.</a:t>
+            </a:r>
+          </a:p>
+        </p:txBody>
+      </p:sp>
+      <p:cxnSp>
+        <p:nvCxnSpPr>
+          <p:cNvPr id="11" name="Conector recto de flecha 10">
+            <a:extLst>
+              <a:ext uri="{FF2B5EF4-FFF2-40B4-BE49-F238E27FC236}">
+                <a16:creationId xmlns:a16="http://schemas.microsoft.com/office/drawing/2014/main" id="{86FBA05B-1931-4BAC-B3AA-76060823E507}"/>
+              </a:ext>
+            </a:extLst>
+          </p:cNvPr>
+          <p:cNvCxnSpPr>
+            <a:cxnSpLocks/>
+            <a:stCxn id="10" idx="2"/>
+          </p:cNvCxnSpPr>
+          <p:nvPr/>
+        </p:nvCxnSpPr>
+        <p:spPr>
+          <a:xfrm flipH="1">
+            <a:off x="2267744" y="2060848"/>
+            <a:ext cx="1080120" cy="629518"/>
+          </a:xfrm>
+          <a:prstGeom prst="straightConnector1">
+            <a:avLst/>
+          </a:prstGeom>
+          <a:ln w="19050">
+            <a:solidFill>
+              <a:srgbClr val="0070C0"/>
+            </a:solidFill>
+            <a:tailEnd type="triangle"/>
+          </a:ln>
+        </p:spPr>
+        <p:style>
+          <a:lnRef idx="1">
+            <a:schemeClr val="accent2"/>
+          </a:lnRef>
+          <a:fillRef idx="0">
+            <a:schemeClr val="accent2"/>
+          </a:fillRef>
+          <a:effectRef idx="0">
+            <a:schemeClr val="accent2"/>
+          </a:effectRef>
+          <a:fontRef idx="minor">
+            <a:schemeClr val="tx1"/>
+          </a:fontRef>
+        </p:style>
+      </p:cxnSp>
+      <p:cxnSp>
+        <p:nvCxnSpPr>
+          <p:cNvPr id="16" name="Conector recto de flecha 15">
+            <a:extLst>
+              <a:ext uri="{FF2B5EF4-FFF2-40B4-BE49-F238E27FC236}">
+                <a16:creationId xmlns:a16="http://schemas.microsoft.com/office/drawing/2014/main" id="{13956D5C-15D7-44C1-9407-84E774A27DF5}"/>
+              </a:ext>
+            </a:extLst>
+          </p:cNvPr>
+          <p:cNvCxnSpPr>
+            <a:cxnSpLocks/>
+            <a:stCxn id="10" idx="2"/>
+          </p:cNvCxnSpPr>
+          <p:nvPr/>
+        </p:nvCxnSpPr>
+        <p:spPr>
+          <a:xfrm>
+            <a:off x="3347864" y="2060848"/>
+            <a:ext cx="216024" cy="629518"/>
+          </a:xfrm>
+          <a:prstGeom prst="straightConnector1">
+            <a:avLst/>
+          </a:prstGeom>
+          <a:ln w="19050">
+            <a:solidFill>
+              <a:srgbClr val="0070C0"/>
+            </a:solidFill>
+            <a:tailEnd type="triangle"/>
+          </a:ln>
+        </p:spPr>
+        <p:style>
+          <a:lnRef idx="1">
+            <a:schemeClr val="accent2"/>
+          </a:lnRef>
+          <a:fillRef idx="0">
+            <a:schemeClr val="accent2"/>
+          </a:fillRef>
+          <a:effectRef idx="0">
+            <a:schemeClr val="accent2"/>
+          </a:effectRef>
+          <a:fontRef idx="minor">
+            <a:schemeClr val="tx1"/>
+          </a:fontRef>
+        </p:style>
+      </p:cxnSp>
+      <p:sp>
+        <p:nvSpPr>
+          <p:cNvPr id="21" name="CuadroTexto 20">
+            <a:extLst>
+              <a:ext uri="{FF2B5EF4-FFF2-40B4-BE49-F238E27FC236}">
+                <a16:creationId xmlns:a16="http://schemas.microsoft.com/office/drawing/2014/main" id="{308C0C01-9C79-46F1-AC76-36E93BD9E10B}"/>
+              </a:ext>
+            </a:extLst>
+          </p:cNvPr>
+          <p:cNvSpPr txBox="1"/>
+          <p:nvPr/>
+        </p:nvSpPr>
+        <p:spPr>
+          <a:xfrm>
+            <a:off x="6588224" y="2134898"/>
+            <a:ext cx="2232248" cy="415498"/>
+          </a:xfrm>
+          <a:prstGeom prst="rect">
+            <a:avLst/>
+          </a:prstGeom>
+          <a:solidFill>
+            <a:schemeClr val="bg1"/>
+          </a:solidFill>
+          <a:ln w="19050">
+            <a:solidFill>
+              <a:srgbClr val="0070C0"/>
+            </a:solidFill>
+          </a:ln>
+        </p:spPr>
+        <p:txBody>
+          <a:bodyPr wrap="square" rtlCol="0">
+            <a:spAutoFit/>
+          </a:bodyPr>
+          <a:lstStyle/>
+          <a:p>
+            <a:pPr algn="just"/>
+            <a:r>
+              <a:rPr lang="en-US" sz="1050" b="1" dirty="0"/>
+              <a:t>Se </a:t>
+            </a:r>
+            <a:r>
+              <a:rPr lang="en-US" sz="1050" b="1" dirty="0" err="1"/>
+              <a:t>muestra</a:t>
+            </a:r>
+            <a:r>
+              <a:rPr lang="en-US" sz="1050" b="1" dirty="0"/>
+              <a:t> </a:t>
+            </a:r>
+            <a:r>
+              <a:rPr lang="en-US" sz="1050" b="1" dirty="0" err="1"/>
+              <a:t>información</a:t>
+            </a:r>
+            <a:r>
+              <a:rPr lang="en-US" sz="1050" b="1" dirty="0"/>
+              <a:t> de PMM’S por </a:t>
+            </a:r>
+            <a:r>
+              <a:rPr lang="en-US" sz="1050" b="1" dirty="0" err="1"/>
+              <a:t>orden</a:t>
+            </a:r>
+            <a:r>
+              <a:rPr lang="en-US" sz="1050" b="1" dirty="0"/>
+              <a:t>.</a:t>
+            </a:r>
+          </a:p>
+        </p:txBody>
+      </p:sp>
+      <p:cxnSp>
+        <p:nvCxnSpPr>
+          <p:cNvPr id="22" name="Conector recto de flecha 21">
+            <a:extLst>
+              <a:ext uri="{FF2B5EF4-FFF2-40B4-BE49-F238E27FC236}">
+                <a16:creationId xmlns:a16="http://schemas.microsoft.com/office/drawing/2014/main" id="{0C9694FA-F8D6-4A7E-B2D7-A502AD81C8CD}"/>
+              </a:ext>
+            </a:extLst>
+          </p:cNvPr>
+          <p:cNvCxnSpPr>
+            <a:cxnSpLocks/>
+            <a:stCxn id="21" idx="1"/>
+          </p:cNvCxnSpPr>
+          <p:nvPr/>
+        </p:nvCxnSpPr>
+        <p:spPr>
+          <a:xfrm flipH="1">
+            <a:off x="6372200" y="2342647"/>
+            <a:ext cx="216024" cy="294265"/>
+          </a:xfrm>
+          <a:prstGeom prst="straightConnector1">
+            <a:avLst/>
+          </a:prstGeom>
+          <a:ln w="19050">
+            <a:solidFill>
+              <a:srgbClr val="0070C0"/>
+            </a:solidFill>
+            <a:tailEnd type="triangle"/>
+          </a:ln>
+        </p:spPr>
+        <p:style>
+          <a:lnRef idx="1">
+            <a:schemeClr val="accent2"/>
+          </a:lnRef>
+          <a:fillRef idx="0">
+            <a:schemeClr val="accent2"/>
+          </a:fillRef>
+          <a:effectRef idx="0">
+            <a:schemeClr val="accent2"/>
+          </a:effectRef>
+          <a:fontRef idx="minor">
+            <a:schemeClr val="tx1"/>
+          </a:fontRef>
+        </p:style>
+      </p:cxnSp>
+      <p:sp>
+        <p:nvSpPr>
+          <p:cNvPr id="25" name="CuadroTexto 24">
+            <a:extLst>
+              <a:ext uri="{FF2B5EF4-FFF2-40B4-BE49-F238E27FC236}">
+                <a16:creationId xmlns:a16="http://schemas.microsoft.com/office/drawing/2014/main" id="{906B32D9-36BE-440B-A86E-ADF5D444436C}"/>
+              </a:ext>
+            </a:extLst>
+          </p:cNvPr>
+          <p:cNvSpPr txBox="1"/>
+          <p:nvPr/>
+        </p:nvSpPr>
+        <p:spPr>
+          <a:xfrm>
+            <a:off x="6228184" y="3215018"/>
+            <a:ext cx="2232248" cy="415498"/>
+          </a:xfrm>
+          <a:prstGeom prst="rect">
+            <a:avLst/>
+          </a:prstGeom>
+          <a:solidFill>
+            <a:schemeClr val="bg1"/>
+          </a:solidFill>
+          <a:ln w="19050">
+            <a:solidFill>
+              <a:srgbClr val="0070C0"/>
+            </a:solidFill>
+          </a:ln>
+        </p:spPr>
+        <p:txBody>
+          <a:bodyPr wrap="square" rtlCol="0">
+            <a:spAutoFit/>
+          </a:bodyPr>
+          <a:lstStyle/>
+          <a:p>
+            <a:pPr algn="just"/>
+            <a:r>
+              <a:rPr lang="en-US" sz="1050" b="1" dirty="0"/>
+              <a:t>Se </a:t>
+            </a:r>
+            <a:r>
+              <a:rPr lang="en-US" sz="1050" b="1" dirty="0" err="1"/>
+              <a:t>muestra</a:t>
+            </a:r>
+            <a:r>
+              <a:rPr lang="en-US" sz="1050" b="1" dirty="0"/>
+              <a:t> </a:t>
+            </a:r>
+            <a:r>
+              <a:rPr lang="en-US" sz="1050" b="1" dirty="0" err="1"/>
+              <a:t>información</a:t>
+            </a:r>
+            <a:r>
+              <a:rPr lang="en-US" sz="1050" b="1" dirty="0"/>
+              <a:t> de PMM’S por </a:t>
+            </a:r>
+            <a:r>
+              <a:rPr lang="en-US" sz="1050" b="1" dirty="0" err="1"/>
+              <a:t>turno</a:t>
+            </a:r>
+            <a:r>
+              <a:rPr lang="en-US" sz="1050" b="1" dirty="0"/>
+              <a:t>.</a:t>
+            </a:r>
+          </a:p>
+        </p:txBody>
+      </p:sp>
+      <p:cxnSp>
+        <p:nvCxnSpPr>
+          <p:cNvPr id="26" name="Conector recto de flecha 25">
+            <a:extLst>
+              <a:ext uri="{FF2B5EF4-FFF2-40B4-BE49-F238E27FC236}">
+                <a16:creationId xmlns:a16="http://schemas.microsoft.com/office/drawing/2014/main" id="{9A91DF77-FBB5-4FD1-B9CB-30F4CBFC2608}"/>
+              </a:ext>
+            </a:extLst>
+          </p:cNvPr>
+          <p:cNvCxnSpPr>
+            <a:cxnSpLocks/>
+            <a:stCxn id="25" idx="1"/>
+          </p:cNvCxnSpPr>
+          <p:nvPr/>
+        </p:nvCxnSpPr>
+        <p:spPr>
+          <a:xfrm flipH="1">
+            <a:off x="5508104" y="3422767"/>
+            <a:ext cx="720080" cy="6233"/>
+          </a:xfrm>
+          <a:prstGeom prst="straightConnector1">
+            <a:avLst/>
+          </a:prstGeom>
+          <a:ln w="19050">
+            <a:solidFill>
+              <a:srgbClr val="0070C0"/>
+            </a:solidFill>
+            <a:tailEnd type="triangle"/>
+          </a:ln>
+        </p:spPr>
+        <p:style>
+          <a:lnRef idx="1">
+            <a:schemeClr val="accent2"/>
+          </a:lnRef>
+          <a:fillRef idx="0">
+            <a:schemeClr val="accent2"/>
+          </a:fillRef>
+          <a:effectRef idx="0">
+            <a:schemeClr val="accent2"/>
+          </a:effectRef>
+          <a:fontRef idx="minor">
+            <a:schemeClr val="tx1"/>
+          </a:fontRef>
+        </p:style>
+      </p:cxnSp>
+    </p:spTree>
+    <p:extLst>
+      <p:ext uri="{BB962C8B-B14F-4D97-AF65-F5344CB8AC3E}">
+        <p14:creationId xmlns:p14="http://schemas.microsoft.com/office/powerpoint/2010/main" val="1330268767"/>
+      </p:ext>
+    </p:extLst>
+  </p:cSld>
+  <p:clrMapOvr>
+    <a:masterClrMapping/>
+  </p:clrMapOvr>
+</p:sld>
+</file>
+
+<file path=ppt/slides/slide4.xml><?xml version="1.0" encoding="utf-8"?>
+<p:sld xmlns:a="http://schemas.openxmlformats.org/drawingml/2006/main" xmlns:r="http://schemas.openxmlformats.org/officeDocument/2006/relationships" xmlns:p="http://schemas.openxmlformats.org/presentationml/2006/main">
+  <p:cSld>
+    <p:spTree>
+      <p:nvGrpSpPr>
+        <p:cNvPr id="1" name=""/>
+        <p:cNvGrpSpPr/>
+        <p:nvPr/>
+      </p:nvGrpSpPr>
+      <p:grpSpPr>
+        <a:xfrm>
+          <a:off x="0" y="0"/>
+          <a:ext cx="0" cy="0"/>
+          <a:chOff x="0" y="0"/>
+          <a:chExt cx="0" cy="0"/>
+        </a:xfrm>
+      </p:grpSpPr>
+      <p:sp>
+        <p:nvSpPr>
+          <p:cNvPr id="5" name="Title 1"/>
+          <p:cNvSpPr txBox="1">
+            <a:spLocks/>
+          </p:cNvSpPr>
+          <p:nvPr/>
+        </p:nvSpPr>
+        <p:spPr>
+          <a:xfrm>
+            <a:off x="1187624" y="2564904"/>
+            <a:ext cx="7772400" cy="1470025"/>
+          </a:xfrm>
+          <a:prstGeom prst="rect">
+            <a:avLst/>
+          </a:prstGeom>
+        </p:spPr>
+        <p:txBody>
+          <a:bodyPr vert="horz" lIns="91440" tIns="45720" rIns="91440" bIns="45720" rtlCol="0" anchor="ctr">
+            <a:normAutofit/>
+          </a:bodyPr>
+          <a:lstStyle>
+            <a:lvl1pPr algn="ctr" defTabSz="914400" rtl="0" eaLnBrk="1" latinLnBrk="0" hangingPunct="1">
+              <a:spcBef>
+                <a:spcPct val="0"/>
+              </a:spcBef>
+              <a:buNone/>
+              <a:defRPr sz="4400" kern="1200">
+                <a:solidFill>
+                  <a:schemeClr val="tx1"/>
+                </a:solidFill>
+                <a:latin typeface="+mj-lt"/>
+                <a:ea typeface="+mj-ea"/>
+                <a:cs typeface="+mj-cs"/>
+              </a:defRPr>
+            </a:lvl1pPr>
+          </a:lstStyle>
+          <a:p>
+            <a:r>
+              <a:rPr lang="es-MX" b="1" dirty="0">
+                <a:latin typeface="Century Gothic" panose="020B0502020202020204" pitchFamily="34" charset="0"/>
+              </a:rPr>
+              <a:t>29/11/2021 – 03/12/2021</a:t>
+            </a:r>
+            <a:endParaRPr lang="es-MX" dirty="0">
+              <a:latin typeface="Century Gothic" panose="020B0502020202020204" pitchFamily="34" charset="0"/>
+            </a:endParaRPr>
+          </a:p>
+        </p:txBody>
+      </p:sp>
+    </p:spTree>
+    <p:extLst>
+      <p:ext uri="{BB962C8B-B14F-4D97-AF65-F5344CB8AC3E}">
+        <p14:creationId xmlns:p14="http://schemas.microsoft.com/office/powerpoint/2010/main" val="1800107651"/>
+      </p:ext>
+    </p:extLst>
+  </p:cSld>
+  <p:clrMapOvr>
+    <a:masterClrMapping/>
+  </p:clrMapOvr>
+</p:sld>
+</file>
+
+<file path=ppt/slides/slide5.xml><?xml version="1.0" encoding="utf-8"?>
 <p:sld xmlns:a="http://schemas.openxmlformats.org/drawingml/2006/main" xmlns:r="http://schemas.openxmlformats.org/officeDocument/2006/relationships" xmlns:p="http://schemas.openxmlformats.org/presentationml/2006/main">
   <p:cSld>
     <p:spTree>
@@ -4287,7 +5669,7 @@
     </p:spTree>
     <p:extLst>
       <p:ext uri="{BB962C8B-B14F-4D97-AF65-F5344CB8AC3E}">
-        <p14:creationId xmlns:p14="http://schemas.microsoft.com/office/powerpoint/2010/main" val="941744193"/>
+        <p14:creationId xmlns:p14="http://schemas.microsoft.com/office/powerpoint/2010/main" val="4069111148"/>
       </p:ext>
     </p:extLst>
   </p:cSld>

</xml_diff>